<commit_message>
Woordenlijst uitgebreid en flyer/PPT bijgewerkt voor avond 1/2-indeling (v3.1.0)
Woordenlijst van 38 naar 54 termen (NL/EN/DE), aangevuld met begrippen uit de
vier nieuwe modules 6-9. Flyer en openingspresentatie maken nu expliciet
onderscheid tussen avond 1 (module 1-5) en avond 2 (module 6-9): de flyer
krijgt een tweede sectie met de vier vervolgmodules, de presentatie krijgt
een nieuwe dia "Avond 2: het vervolg" en de praktische-infodia's koppelen
elke datum aan de bijbehorende modules.

Co-Authored-By: Claude Sonnet 5 <noreply@anthropic.com>
</commit_message>
<xml_diff>
--- a/marketing/opening-presentatie.pptx
+++ b/marketing/opening-presentatie.pptx
@@ -10,6 +10,7 @@
     <p:sldId id="258" r:id="rId4"/>
     <p:sldId id="259" r:id="rId5"/>
     <p:sldId id="260" r:id="rId6"/>
+    <p:sldId id="266" r:id="rId17"/>
     <p:sldId id="261" r:id="rId7"/>
     <p:sldId id="262" r:id="rId8"/>
     <p:sldId id="263" r:id="rId9"/>
@@ -2099,6 +2100,1178 @@
 </p:sld>
 </file>
 
+<file path=ppt/slides/slide11.xml><?xml version="1.0" encoding="utf-8"?>
+<p:sld xmlns:a="http://schemas.openxmlformats.org/drawingml/2006/main" xmlns:p="http://schemas.openxmlformats.org/presentationml/2006/main" xmlns:r="http://schemas.openxmlformats.org/officeDocument/2006/relationships">
+  <p:cSld>
+    <p:bg>
+      <p:bgPr>
+        <a:solidFill>
+          <a:srgbClr val="EFF4F1"/>
+        </a:solidFill>
+        <a:effectLst/>
+      </p:bgPr>
+    </p:bg>
+    <p:spTree>
+      <p:nvGrpSpPr>
+        <p:cNvPr id="1" name=""/>
+        <p:cNvGrpSpPr/>
+        <p:nvPr/>
+      </p:nvGrpSpPr>
+      <p:grpSpPr/>
+      <p:sp>
+        <p:nvSpPr>
+          <p:cNvPr id="2" name="TextBox 1"/>
+          <p:cNvSpPr txBox="1"/>
+          <p:nvPr/>
+        </p:nvSpPr>
+        <p:spPr>
+          <a:xfrm>
+            <a:off x="640080" y="457200"/>
+            <a:ext cx="5486400" cy="292608"/>
+          </a:xfrm>
+          <a:prstGeom prst="rect">
+            <a:avLst/>
+          </a:prstGeom>
+          <a:noFill/>
+        </p:spPr>
+        <p:txBody>
+          <a:bodyPr wrap="square" lIns="0" rIns="0" tIns="0" bIns="0" anchor="ctr">
+            <a:spAutoFit/>
+          </a:bodyPr>
+          <a:lstStyle/>
+          <a:p>
+            <a:pPr algn="l"/>
+            <a:r>
+              <a:rPr sz="1200" b="1">
+                <a:solidFill>
+                  <a:srgbClr val="124E54"/>
+                </a:solidFill>
+                <a:latin typeface="Calibri"/>
+              </a:rPr>
+              <a:t>AVOND 2</a:t>
+            </a:r>
+          </a:p>
+        </p:txBody>
+      </p:sp>
+      <p:sp>
+        <p:nvSpPr>
+          <p:cNvPr id="3" name="TextBox 2"/>
+          <p:cNvSpPr txBox="1"/>
+          <p:nvPr/>
+        </p:nvSpPr>
+        <p:spPr>
+          <a:xfrm>
+            <a:off x="640080" y="731520"/>
+            <a:ext cx="10881360" cy="640080"/>
+          </a:xfrm>
+          <a:prstGeom prst="rect">
+            <a:avLst/>
+          </a:prstGeom>
+          <a:noFill/>
+        </p:spPr>
+        <p:txBody>
+          <a:bodyPr wrap="square" lIns="0" rIns="0" tIns="0" bIns="0" anchor="ctr">
+            <a:spAutoFit/>
+          </a:bodyPr>
+          <a:lstStyle/>
+          <a:p>
+            <a:pPr algn="l"/>
+            <a:r>
+              <a:rPr sz="3200" b="1">
+                <a:solidFill>
+                  <a:srgbClr val="17323A"/>
+                </a:solidFill>
+                <a:latin typeface="Cambria"/>
+              </a:rPr>
+              <a:t>Avond 2: het vervolg</a:t>
+            </a:r>
+          </a:p>
+        </p:txBody>
+      </p:sp>
+      <p:sp>
+        <p:nvSpPr>
+          <p:cNvPr id="4" name="Rounded Rectangle 3"/>
+          <p:cNvSpPr/>
+          <p:nvPr/>
+        </p:nvSpPr>
+        <p:spPr>
+          <a:xfrm>
+            <a:off x="1568196" y="1600200"/>
+            <a:ext cx="2139696" cy="4297680"/>
+          </a:xfrm>
+          <a:prstGeom prst="roundRect">
+            <a:avLst>
+              <a:gd name="adj" fmla="val 5128"/>
+            </a:avLst>
+          </a:prstGeom>
+          <a:solidFill>
+            <a:srgbClr val="FFFFFF"/>
+          </a:solidFill>
+          <a:ln w="12700">
+            <a:solidFill>
+              <a:srgbClr val="DCE6E0"/>
+            </a:solidFill>
+          </a:ln>
+          <a:effectLst/>
+        </p:spPr>
+        <p:style>
+          <a:lnRef idx="1">
+            <a:schemeClr val="accent1"/>
+          </a:lnRef>
+          <a:fillRef idx="3">
+            <a:schemeClr val="accent1"/>
+          </a:fillRef>
+          <a:effectRef idx="2">
+            <a:schemeClr val="accent1"/>
+          </a:effectRef>
+          <a:fontRef idx="minor">
+            <a:schemeClr val="lt1"/>
+          </a:fontRef>
+        </p:style>
+        <p:txBody>
+          <a:bodyPr rtlCol="0" anchor="ctr"/>
+          <a:lstStyle/>
+          <a:p>
+            <a:pPr algn="ctr"/>
+          </a:p>
+        </p:txBody>
+      </p:sp>
+      <p:sp>
+        <p:nvSpPr>
+          <p:cNvPr id="5" name="Oval 4"/>
+          <p:cNvSpPr/>
+          <p:nvPr/>
+        </p:nvSpPr>
+        <p:spPr>
+          <a:xfrm>
+            <a:off x="2409444" y="1920240"/>
+            <a:ext cx="457200" cy="457200"/>
+          </a:xfrm>
+          <a:prstGeom prst="ellipse">
+            <a:avLst/>
+          </a:prstGeom>
+          <a:solidFill>
+            <a:srgbClr val="E2872F"/>
+          </a:solidFill>
+          <a:ln>
+            <a:noFill/>
+          </a:ln>
+          <a:effectLst/>
+        </p:spPr>
+        <p:style>
+          <a:lnRef idx="1">
+            <a:schemeClr val="accent1"/>
+          </a:lnRef>
+          <a:fillRef idx="3">
+            <a:schemeClr val="accent1"/>
+          </a:fillRef>
+          <a:effectRef idx="2">
+            <a:schemeClr val="accent1"/>
+          </a:effectRef>
+          <a:fontRef idx="minor">
+            <a:schemeClr val="lt1"/>
+          </a:fontRef>
+        </p:style>
+        <p:txBody>
+          <a:bodyPr rtlCol="0" anchor="ctr"/>
+          <a:lstStyle/>
+          <a:p>
+            <a:pPr algn="ctr"/>
+          </a:p>
+        </p:txBody>
+      </p:sp>
+      <p:sp>
+        <p:nvSpPr>
+          <p:cNvPr id="6" name="TextBox 5"/>
+          <p:cNvSpPr txBox="1"/>
+          <p:nvPr/>
+        </p:nvSpPr>
+        <p:spPr>
+          <a:xfrm>
+            <a:off x="2409444" y="1920240"/>
+            <a:ext cx="457200" cy="457200"/>
+          </a:xfrm>
+          <a:prstGeom prst="rect">
+            <a:avLst/>
+          </a:prstGeom>
+          <a:noFill/>
+        </p:spPr>
+        <p:txBody>
+          <a:bodyPr wrap="square" lIns="0" rIns="0" tIns="0" bIns="0" anchor="ctr">
+            <a:spAutoFit/>
+          </a:bodyPr>
+          <a:lstStyle/>
+          <a:p>
+            <a:pPr algn="ctr"/>
+            <a:r>
+              <a:rPr sz="1600" b="1">
+                <a:solidFill>
+                  <a:srgbClr val="FFFFFF"/>
+                </a:solidFill>
+                <a:latin typeface="Cambria"/>
+              </a:rPr>
+              <a:t>6</a:t>
+            </a:r>
+          </a:p>
+        </p:txBody>
+      </p:sp>
+      <p:sp>
+        <p:nvSpPr>
+          <p:cNvPr id="7" name="Oval 6"/>
+          <p:cNvSpPr/>
+          <p:nvPr/>
+        </p:nvSpPr>
+        <p:spPr>
+          <a:xfrm>
+            <a:off x="2308860" y="2560320"/>
+            <a:ext cx="658368" cy="658368"/>
+          </a:xfrm>
+          <a:prstGeom prst="ellipse">
+            <a:avLst/>
+          </a:prstGeom>
+          <a:solidFill>
+            <a:srgbClr val="1C6E76"/>
+          </a:solidFill>
+          <a:ln>
+            <a:noFill/>
+          </a:ln>
+          <a:effectLst/>
+        </p:spPr>
+        <p:style>
+          <a:lnRef idx="1">
+            <a:schemeClr val="accent1"/>
+          </a:lnRef>
+          <a:fillRef idx="3">
+            <a:schemeClr val="accent1"/>
+          </a:fillRef>
+          <a:effectRef idx="2">
+            <a:schemeClr val="accent1"/>
+          </a:effectRef>
+          <a:fontRef idx="minor">
+            <a:schemeClr val="lt1"/>
+          </a:fontRef>
+        </p:style>
+        <p:txBody>
+          <a:bodyPr rtlCol="0" anchor="ctr"/>
+          <a:lstStyle/>
+          <a:p>
+            <a:pPr algn="ctr"/>
+          </a:p>
+        </p:txBody>
+      </p:sp>
+      <p:pic>
+        <p:nvPicPr>
+          <p:cNvPr id="8" name="Picture 7" descr="camera.png"/>
+          <p:cNvPicPr>
+            <a:picLocks noChangeAspect="1"/>
+          </p:cNvPicPr>
+          <p:nvPr/>
+        </p:nvPicPr>
+        <p:blipFill>
+          <a:blip r:embed="rId2"/>
+          <a:stretch>
+            <a:fillRect/>
+          </a:stretch>
+        </p:blipFill>
+        <p:spPr>
+          <a:xfrm>
+            <a:off x="2473452" y="2724912"/>
+            <a:ext cx="329184" cy="329184"/>
+          </a:xfrm>
+          <a:prstGeom prst="rect">
+            <a:avLst/>
+          </a:prstGeom>
+        </p:spPr>
+      </p:pic>
+      <p:sp>
+        <p:nvSpPr>
+          <p:cNvPr id="9" name="TextBox 8"/>
+          <p:cNvSpPr txBox="1"/>
+          <p:nvPr/>
+        </p:nvSpPr>
+        <p:spPr>
+          <a:xfrm>
+            <a:off x="1677924" y="3474720"/>
+            <a:ext cx="1920240" cy="960120"/>
+          </a:xfrm>
+          <a:prstGeom prst="rect">
+            <a:avLst/>
+          </a:prstGeom>
+          <a:noFill/>
+        </p:spPr>
+        <p:txBody>
+          <a:bodyPr wrap="square" lIns="0" rIns="0" tIns="0" bIns="0" anchor="ctr">
+            <a:spAutoFit/>
+          </a:bodyPr>
+          <a:lstStyle/>
+          <a:p>
+            <a:pPr algn="ctr"/>
+            <a:r>
+              <a:rPr sz="1450" b="1">
+                <a:solidFill>
+                  <a:srgbClr val="17323A"/>
+                </a:solidFill>
+                <a:latin typeface="Cambria"/>
+              </a:rPr>
+              <a:t>Foto's &amp; Video's</a:t>
+            </a:r>
+          </a:p>
+        </p:txBody>
+      </p:sp>
+      <p:sp>
+        <p:nvSpPr>
+          <p:cNvPr id="10" name="TextBox 9"/>
+          <p:cNvSpPr txBox="1"/>
+          <p:nvPr/>
+        </p:nvSpPr>
+        <p:spPr>
+          <a:xfrm>
+            <a:off x="1705356" y="4480560"/>
+            <a:ext cx="1865376" cy="1280160"/>
+          </a:xfrm>
+          <a:prstGeom prst="rect">
+            <a:avLst/>
+          </a:prstGeom>
+          <a:noFill/>
+        </p:spPr>
+        <p:txBody>
+          <a:bodyPr wrap="square" lIns="0" rIns="0" tIns="0" bIns="0" anchor="ctr">
+            <a:spAutoFit/>
+          </a:bodyPr>
+          <a:lstStyle/>
+          <a:p>
+            <a:pPr algn="ctr">
+              <a:lnSpc>
+                <a:spcPct val="125000"/>
+              </a:lnSpc>
+            </a:pPr>
+            <a:r>
+              <a:rPr sz="1100" b="0">
+                <a:solidFill>
+                  <a:srgbClr val="45585C"/>
+                </a:solidFill>
+                <a:latin typeface="Calibri"/>
+              </a:rPr>
+              <a:t>Maken, bewerken, albums, delen met familie</a:t>
+            </a:r>
+          </a:p>
+        </p:txBody>
+      </p:sp>
+      <p:sp>
+        <p:nvSpPr>
+          <p:cNvPr id="11" name="Rounded Rectangle 10"/>
+          <p:cNvSpPr/>
+          <p:nvPr/>
+        </p:nvSpPr>
+        <p:spPr>
+          <a:xfrm>
+            <a:off x="3872484" y="1600200"/>
+            <a:ext cx="2139696" cy="4297680"/>
+          </a:xfrm>
+          <a:prstGeom prst="roundRect">
+            <a:avLst>
+              <a:gd name="adj" fmla="val 5128"/>
+            </a:avLst>
+          </a:prstGeom>
+          <a:solidFill>
+            <a:srgbClr val="FFFFFF"/>
+          </a:solidFill>
+          <a:ln w="12700">
+            <a:solidFill>
+              <a:srgbClr val="DCE6E0"/>
+            </a:solidFill>
+          </a:ln>
+          <a:effectLst/>
+        </p:spPr>
+        <p:style>
+          <a:lnRef idx="1">
+            <a:schemeClr val="accent1"/>
+          </a:lnRef>
+          <a:fillRef idx="3">
+            <a:schemeClr val="accent1"/>
+          </a:fillRef>
+          <a:effectRef idx="2">
+            <a:schemeClr val="accent1"/>
+          </a:effectRef>
+          <a:fontRef idx="minor">
+            <a:schemeClr val="lt1"/>
+          </a:fontRef>
+        </p:style>
+        <p:txBody>
+          <a:bodyPr rtlCol="0" anchor="ctr"/>
+          <a:lstStyle/>
+          <a:p>
+            <a:pPr algn="ctr"/>
+          </a:p>
+        </p:txBody>
+      </p:sp>
+      <p:sp>
+        <p:nvSpPr>
+          <p:cNvPr id="12" name="Oval 11"/>
+          <p:cNvSpPr/>
+          <p:nvPr/>
+        </p:nvSpPr>
+        <p:spPr>
+          <a:xfrm>
+            <a:off x="4713732" y="1920240"/>
+            <a:ext cx="457200" cy="457200"/>
+          </a:xfrm>
+          <a:prstGeom prst="ellipse">
+            <a:avLst/>
+          </a:prstGeom>
+          <a:solidFill>
+            <a:srgbClr val="E2872F"/>
+          </a:solidFill>
+          <a:ln>
+            <a:noFill/>
+          </a:ln>
+          <a:effectLst/>
+        </p:spPr>
+        <p:style>
+          <a:lnRef idx="1">
+            <a:schemeClr val="accent1"/>
+          </a:lnRef>
+          <a:fillRef idx="3">
+            <a:schemeClr val="accent1"/>
+          </a:fillRef>
+          <a:effectRef idx="2">
+            <a:schemeClr val="accent1"/>
+          </a:effectRef>
+          <a:fontRef idx="minor">
+            <a:schemeClr val="lt1"/>
+          </a:fontRef>
+        </p:style>
+        <p:txBody>
+          <a:bodyPr rtlCol="0" anchor="ctr"/>
+          <a:lstStyle/>
+          <a:p>
+            <a:pPr algn="ctr"/>
+          </a:p>
+        </p:txBody>
+      </p:sp>
+      <p:sp>
+        <p:nvSpPr>
+          <p:cNvPr id="13" name="TextBox 12"/>
+          <p:cNvSpPr txBox="1"/>
+          <p:nvPr/>
+        </p:nvSpPr>
+        <p:spPr>
+          <a:xfrm>
+            <a:off x="4713732" y="1920240"/>
+            <a:ext cx="457200" cy="457200"/>
+          </a:xfrm>
+          <a:prstGeom prst="rect">
+            <a:avLst/>
+          </a:prstGeom>
+          <a:noFill/>
+        </p:spPr>
+        <p:txBody>
+          <a:bodyPr wrap="square" lIns="0" rIns="0" tIns="0" bIns="0" anchor="ctr">
+            <a:spAutoFit/>
+          </a:bodyPr>
+          <a:lstStyle/>
+          <a:p>
+            <a:pPr algn="ctr"/>
+            <a:r>
+              <a:rPr sz="1600" b="1">
+                <a:solidFill>
+                  <a:srgbClr val="FFFFFF"/>
+                </a:solidFill>
+                <a:latin typeface="Cambria"/>
+              </a:rPr>
+              <a:t>7</a:t>
+            </a:r>
+          </a:p>
+        </p:txBody>
+      </p:sp>
+      <p:sp>
+        <p:nvSpPr>
+          <p:cNvPr id="14" name="Oval 13"/>
+          <p:cNvSpPr/>
+          <p:nvPr/>
+        </p:nvSpPr>
+        <p:spPr>
+          <a:xfrm>
+            <a:off x="4613148" y="2560320"/>
+            <a:ext cx="658368" cy="658368"/>
+          </a:xfrm>
+          <a:prstGeom prst="ellipse">
+            <a:avLst/>
+          </a:prstGeom>
+          <a:solidFill>
+            <a:srgbClr val="1C6E76"/>
+          </a:solidFill>
+          <a:ln>
+            <a:noFill/>
+          </a:ln>
+          <a:effectLst/>
+        </p:spPr>
+        <p:style>
+          <a:lnRef idx="1">
+            <a:schemeClr val="accent1"/>
+          </a:lnRef>
+          <a:fillRef idx="3">
+            <a:schemeClr val="accent1"/>
+          </a:fillRef>
+          <a:effectRef idx="2">
+            <a:schemeClr val="accent1"/>
+          </a:effectRef>
+          <a:fontRef idx="minor">
+            <a:schemeClr val="lt1"/>
+          </a:fontRef>
+        </p:style>
+        <p:txBody>
+          <a:bodyPr rtlCol="0" anchor="ctr"/>
+          <a:lstStyle/>
+          <a:p>
+            <a:pPr algn="ctr"/>
+          </a:p>
+        </p:txBody>
+      </p:sp>
+      <p:pic>
+        <p:nvPicPr>
+          <p:cNvPr id="15" name="Picture 14" descr="shopping-bag.png"/>
+          <p:cNvPicPr>
+            <a:picLocks noChangeAspect="1"/>
+          </p:cNvPicPr>
+          <p:nvPr/>
+        </p:nvPicPr>
+        <p:blipFill>
+          <a:blip r:embed="rId3"/>
+          <a:stretch>
+            <a:fillRect/>
+          </a:stretch>
+        </p:blipFill>
+        <p:spPr>
+          <a:xfrm>
+            <a:off x="4777740" y="2724912"/>
+            <a:ext cx="329184" cy="329184"/>
+          </a:xfrm>
+          <a:prstGeom prst="rect">
+            <a:avLst/>
+          </a:prstGeom>
+        </p:spPr>
+      </p:pic>
+      <p:sp>
+        <p:nvSpPr>
+          <p:cNvPr id="16" name="TextBox 15"/>
+          <p:cNvSpPr txBox="1"/>
+          <p:nvPr/>
+        </p:nvSpPr>
+        <p:spPr>
+          <a:xfrm>
+            <a:off x="3982212" y="3474720"/>
+            <a:ext cx="1920240" cy="960120"/>
+          </a:xfrm>
+          <a:prstGeom prst="rect">
+            <a:avLst/>
+          </a:prstGeom>
+          <a:noFill/>
+        </p:spPr>
+        <p:txBody>
+          <a:bodyPr wrap="square" lIns="0" rIns="0" tIns="0" bIns="0" anchor="ctr">
+            <a:spAutoFit/>
+          </a:bodyPr>
+          <a:lstStyle/>
+          <a:p>
+            <a:pPr algn="ctr"/>
+            <a:r>
+              <a:rPr sz="1450" b="1">
+                <a:solidFill>
+                  <a:srgbClr val="17323A"/>
+                </a:solidFill>
+                <a:latin typeface="Cambria"/>
+              </a:rPr>
+              <a:t>Veilig Online Winkelen</a:t>
+            </a:r>
+          </a:p>
+        </p:txBody>
+      </p:sp>
+      <p:sp>
+        <p:nvSpPr>
+          <p:cNvPr id="17" name="TextBox 16"/>
+          <p:cNvSpPr txBox="1"/>
+          <p:nvPr/>
+        </p:nvSpPr>
+        <p:spPr>
+          <a:xfrm>
+            <a:off x="4009644" y="4480560"/>
+            <a:ext cx="1865376" cy="1280160"/>
+          </a:xfrm>
+          <a:prstGeom prst="rect">
+            <a:avLst/>
+          </a:prstGeom>
+          <a:noFill/>
+        </p:spPr>
+        <p:txBody>
+          <a:bodyPr wrap="square" lIns="0" rIns="0" tIns="0" bIns="0" anchor="ctr">
+            <a:spAutoFit/>
+          </a:bodyPr>
+          <a:lstStyle/>
+          <a:p>
+            <a:pPr algn="ctr">
+              <a:lnSpc>
+                <a:spcPct val="125000"/>
+              </a:lnSpc>
+            </a:pPr>
+            <a:r>
+              <a:rPr sz="1100" b="0">
+                <a:solidFill>
+                  <a:srgbClr val="45585C"/>
+                </a:solidFill>
+                <a:latin typeface="Calibri"/>
+              </a:rPr>
+              <a:t>Betrouwbare shops, veilig betalen, bezorging</a:t>
+            </a:r>
+          </a:p>
+        </p:txBody>
+      </p:sp>
+      <p:sp>
+        <p:nvSpPr>
+          <p:cNvPr id="18" name="Rounded Rectangle 17"/>
+          <p:cNvSpPr/>
+          <p:nvPr/>
+        </p:nvSpPr>
+        <p:spPr>
+          <a:xfrm>
+            <a:off x="6176772" y="1600200"/>
+            <a:ext cx="2139696" cy="4297680"/>
+          </a:xfrm>
+          <a:prstGeom prst="roundRect">
+            <a:avLst>
+              <a:gd name="adj" fmla="val 5128"/>
+            </a:avLst>
+          </a:prstGeom>
+          <a:solidFill>
+            <a:srgbClr val="FFFFFF"/>
+          </a:solidFill>
+          <a:ln w="12700">
+            <a:solidFill>
+              <a:srgbClr val="DCE6E0"/>
+            </a:solidFill>
+          </a:ln>
+          <a:effectLst/>
+        </p:spPr>
+        <p:style>
+          <a:lnRef idx="1">
+            <a:schemeClr val="accent1"/>
+          </a:lnRef>
+          <a:fillRef idx="3">
+            <a:schemeClr val="accent1"/>
+          </a:fillRef>
+          <a:effectRef idx="2">
+            <a:schemeClr val="accent1"/>
+          </a:effectRef>
+          <a:fontRef idx="minor">
+            <a:schemeClr val="lt1"/>
+          </a:fontRef>
+        </p:style>
+        <p:txBody>
+          <a:bodyPr rtlCol="0" anchor="ctr"/>
+          <a:lstStyle/>
+          <a:p>
+            <a:pPr algn="ctr"/>
+          </a:p>
+        </p:txBody>
+      </p:sp>
+      <p:sp>
+        <p:nvSpPr>
+          <p:cNvPr id="19" name="Oval 18"/>
+          <p:cNvSpPr/>
+          <p:nvPr/>
+        </p:nvSpPr>
+        <p:spPr>
+          <a:xfrm>
+            <a:off x="7018020" y="1920240"/>
+            <a:ext cx="457200" cy="457200"/>
+          </a:xfrm>
+          <a:prstGeom prst="ellipse">
+            <a:avLst/>
+          </a:prstGeom>
+          <a:solidFill>
+            <a:srgbClr val="E2872F"/>
+          </a:solidFill>
+          <a:ln>
+            <a:noFill/>
+          </a:ln>
+          <a:effectLst/>
+        </p:spPr>
+        <p:style>
+          <a:lnRef idx="1">
+            <a:schemeClr val="accent1"/>
+          </a:lnRef>
+          <a:fillRef idx="3">
+            <a:schemeClr val="accent1"/>
+          </a:fillRef>
+          <a:effectRef idx="2">
+            <a:schemeClr val="accent1"/>
+          </a:effectRef>
+          <a:fontRef idx="minor">
+            <a:schemeClr val="lt1"/>
+          </a:fontRef>
+        </p:style>
+        <p:txBody>
+          <a:bodyPr rtlCol="0" anchor="ctr"/>
+          <a:lstStyle/>
+          <a:p>
+            <a:pPr algn="ctr"/>
+          </a:p>
+        </p:txBody>
+      </p:sp>
+      <p:sp>
+        <p:nvSpPr>
+          <p:cNvPr id="20" name="TextBox 19"/>
+          <p:cNvSpPr txBox="1"/>
+          <p:nvPr/>
+        </p:nvSpPr>
+        <p:spPr>
+          <a:xfrm>
+            <a:off x="7018020" y="1920240"/>
+            <a:ext cx="457200" cy="457200"/>
+          </a:xfrm>
+          <a:prstGeom prst="rect">
+            <a:avLst/>
+          </a:prstGeom>
+          <a:noFill/>
+        </p:spPr>
+        <p:txBody>
+          <a:bodyPr wrap="square" lIns="0" rIns="0" tIns="0" bIns="0" anchor="ctr">
+            <a:spAutoFit/>
+          </a:bodyPr>
+          <a:lstStyle/>
+          <a:p>
+            <a:pPr algn="ctr"/>
+            <a:r>
+              <a:rPr sz="1600" b="1">
+                <a:solidFill>
+                  <a:srgbClr val="FFFFFF"/>
+                </a:solidFill>
+                <a:latin typeface="Cambria"/>
+              </a:rPr>
+              <a:t>8</a:t>
+            </a:r>
+          </a:p>
+        </p:txBody>
+      </p:sp>
+      <p:sp>
+        <p:nvSpPr>
+          <p:cNvPr id="21" name="Oval 20"/>
+          <p:cNvSpPr/>
+          <p:nvPr/>
+        </p:nvSpPr>
+        <p:spPr>
+          <a:xfrm>
+            <a:off x="6917436" y="2560320"/>
+            <a:ext cx="658368" cy="658368"/>
+          </a:xfrm>
+          <a:prstGeom prst="ellipse">
+            <a:avLst/>
+          </a:prstGeom>
+          <a:solidFill>
+            <a:srgbClr val="1C6E76"/>
+          </a:solidFill>
+          <a:ln>
+            <a:noFill/>
+          </a:ln>
+          <a:effectLst/>
+        </p:spPr>
+        <p:style>
+          <a:lnRef idx="1">
+            <a:schemeClr val="accent1"/>
+          </a:lnRef>
+          <a:fillRef idx="3">
+            <a:schemeClr val="accent1"/>
+          </a:fillRef>
+          <a:effectRef idx="2">
+            <a:schemeClr val="accent1"/>
+          </a:effectRef>
+          <a:fontRef idx="minor">
+            <a:schemeClr val="lt1"/>
+          </a:fontRef>
+        </p:style>
+        <p:txBody>
+          <a:bodyPr rtlCol="0" anchor="ctr"/>
+          <a:lstStyle/>
+          <a:p>
+            <a:pPr algn="ctr"/>
+          </a:p>
+        </p:txBody>
+      </p:sp>
+      <p:pic>
+        <p:nvPicPr>
+          <p:cNvPr id="22" name="Picture 21" descr="sparkles.png"/>
+          <p:cNvPicPr>
+            <a:picLocks noChangeAspect="1"/>
+          </p:cNvPicPr>
+          <p:nvPr/>
+        </p:nvPicPr>
+        <p:blipFill>
+          <a:blip r:embed="rId4"/>
+          <a:stretch>
+            <a:fillRect/>
+          </a:stretch>
+        </p:blipFill>
+        <p:spPr>
+          <a:xfrm>
+            <a:off x="7082028" y="2724912"/>
+            <a:ext cx="329184" cy="329184"/>
+          </a:xfrm>
+          <a:prstGeom prst="rect">
+            <a:avLst/>
+          </a:prstGeom>
+        </p:spPr>
+      </p:pic>
+      <p:sp>
+        <p:nvSpPr>
+          <p:cNvPr id="23" name="TextBox 22"/>
+          <p:cNvSpPr txBox="1"/>
+          <p:nvPr/>
+        </p:nvSpPr>
+        <p:spPr>
+          <a:xfrm>
+            <a:off x="6286500" y="3474720"/>
+            <a:ext cx="1920240" cy="960120"/>
+          </a:xfrm>
+          <a:prstGeom prst="rect">
+            <a:avLst/>
+          </a:prstGeom>
+          <a:noFill/>
+        </p:spPr>
+        <p:txBody>
+          <a:bodyPr wrap="square" lIns="0" rIns="0" tIns="0" bIns="0" anchor="ctr">
+            <a:spAutoFit/>
+          </a:bodyPr>
+          <a:lstStyle/>
+          <a:p>
+            <a:pPr algn="ctr"/>
+            <a:r>
+              <a:rPr sz="1450" b="1">
+                <a:solidFill>
+                  <a:srgbClr val="17323A"/>
+                </a:solidFill>
+                <a:latin typeface="Cambria"/>
+              </a:rPr>
+              <a:t>Slimme Telefoon &amp; AI</a:t>
+            </a:r>
+          </a:p>
+        </p:txBody>
+      </p:sp>
+      <p:sp>
+        <p:nvSpPr>
+          <p:cNvPr id="24" name="TextBox 23"/>
+          <p:cNvSpPr txBox="1"/>
+          <p:nvPr/>
+        </p:nvSpPr>
+        <p:spPr>
+          <a:xfrm>
+            <a:off x="6313932" y="4480560"/>
+            <a:ext cx="1865376" cy="1280160"/>
+          </a:xfrm>
+          <a:prstGeom prst="rect">
+            <a:avLst/>
+          </a:prstGeom>
+          <a:noFill/>
+        </p:spPr>
+        <p:txBody>
+          <a:bodyPr wrap="square" lIns="0" rIns="0" tIns="0" bIns="0" anchor="ctr">
+            <a:spAutoFit/>
+          </a:bodyPr>
+          <a:lstStyle/>
+          <a:p>
+            <a:pPr algn="ctr">
+              <a:lnSpc>
+                <a:spcPct val="125000"/>
+              </a:lnSpc>
+            </a:pPr>
+            <a:r>
+              <a:rPr sz="1100" b="0">
+                <a:solidFill>
+                  <a:srgbClr val="45585C"/>
+                </a:solidFill>
+                <a:latin typeface="Calibri"/>
+              </a:rPr>
+              <a:t>Instellingen, apps, AI voor alledaagse vragen</a:t>
+            </a:r>
+          </a:p>
+        </p:txBody>
+      </p:sp>
+      <p:sp>
+        <p:nvSpPr>
+          <p:cNvPr id="25" name="Rounded Rectangle 24"/>
+          <p:cNvSpPr/>
+          <p:nvPr/>
+        </p:nvSpPr>
+        <p:spPr>
+          <a:xfrm>
+            <a:off x="8481060" y="1600200"/>
+            <a:ext cx="2139696" cy="4297680"/>
+          </a:xfrm>
+          <a:prstGeom prst="roundRect">
+            <a:avLst>
+              <a:gd name="adj" fmla="val 5128"/>
+            </a:avLst>
+          </a:prstGeom>
+          <a:solidFill>
+            <a:srgbClr val="FFFFFF"/>
+          </a:solidFill>
+          <a:ln w="12700">
+            <a:solidFill>
+              <a:srgbClr val="DCE6E0"/>
+            </a:solidFill>
+          </a:ln>
+          <a:effectLst/>
+        </p:spPr>
+        <p:style>
+          <a:lnRef idx="1">
+            <a:schemeClr val="accent1"/>
+          </a:lnRef>
+          <a:fillRef idx="3">
+            <a:schemeClr val="accent1"/>
+          </a:fillRef>
+          <a:effectRef idx="2">
+            <a:schemeClr val="accent1"/>
+          </a:effectRef>
+          <a:fontRef idx="minor">
+            <a:schemeClr val="lt1"/>
+          </a:fontRef>
+        </p:style>
+        <p:txBody>
+          <a:bodyPr rtlCol="0" anchor="ctr"/>
+          <a:lstStyle/>
+          <a:p>
+            <a:pPr algn="ctr"/>
+          </a:p>
+        </p:txBody>
+      </p:sp>
+      <p:sp>
+        <p:nvSpPr>
+          <p:cNvPr id="26" name="Oval 25"/>
+          <p:cNvSpPr/>
+          <p:nvPr/>
+        </p:nvSpPr>
+        <p:spPr>
+          <a:xfrm>
+            <a:off x="9322308" y="1920240"/>
+            <a:ext cx="457200" cy="457200"/>
+          </a:xfrm>
+          <a:prstGeom prst="ellipse">
+            <a:avLst/>
+          </a:prstGeom>
+          <a:solidFill>
+            <a:srgbClr val="E2872F"/>
+          </a:solidFill>
+          <a:ln>
+            <a:noFill/>
+          </a:ln>
+          <a:effectLst/>
+        </p:spPr>
+        <p:style>
+          <a:lnRef idx="1">
+            <a:schemeClr val="accent1"/>
+          </a:lnRef>
+          <a:fillRef idx="3">
+            <a:schemeClr val="accent1"/>
+          </a:fillRef>
+          <a:effectRef idx="2">
+            <a:schemeClr val="accent1"/>
+          </a:effectRef>
+          <a:fontRef idx="minor">
+            <a:schemeClr val="lt1"/>
+          </a:fontRef>
+        </p:style>
+        <p:txBody>
+          <a:bodyPr rtlCol="0" anchor="ctr"/>
+          <a:lstStyle/>
+          <a:p>
+            <a:pPr algn="ctr"/>
+          </a:p>
+        </p:txBody>
+      </p:sp>
+      <p:sp>
+        <p:nvSpPr>
+          <p:cNvPr id="27" name="TextBox 26"/>
+          <p:cNvSpPr txBox="1"/>
+          <p:nvPr/>
+        </p:nvSpPr>
+        <p:spPr>
+          <a:xfrm>
+            <a:off x="9322308" y="1920240"/>
+            <a:ext cx="457200" cy="457200"/>
+          </a:xfrm>
+          <a:prstGeom prst="rect">
+            <a:avLst/>
+          </a:prstGeom>
+          <a:noFill/>
+        </p:spPr>
+        <p:txBody>
+          <a:bodyPr wrap="square" lIns="0" rIns="0" tIns="0" bIns="0" anchor="ctr">
+            <a:spAutoFit/>
+          </a:bodyPr>
+          <a:lstStyle/>
+          <a:p>
+            <a:pPr algn="ctr"/>
+            <a:r>
+              <a:rPr sz="1600" b="1">
+                <a:solidFill>
+                  <a:srgbClr val="FFFFFF"/>
+                </a:solidFill>
+                <a:latin typeface="Cambria"/>
+              </a:rPr>
+              <a:t>9</a:t>
+            </a:r>
+          </a:p>
+        </p:txBody>
+      </p:sp>
+      <p:sp>
+        <p:nvSpPr>
+          <p:cNvPr id="28" name="Oval 27"/>
+          <p:cNvSpPr/>
+          <p:nvPr/>
+        </p:nvSpPr>
+        <p:spPr>
+          <a:xfrm>
+            <a:off x="9221724" y="2560320"/>
+            <a:ext cx="658368" cy="658368"/>
+          </a:xfrm>
+          <a:prstGeom prst="ellipse">
+            <a:avLst/>
+          </a:prstGeom>
+          <a:solidFill>
+            <a:srgbClr val="1C6E76"/>
+          </a:solidFill>
+          <a:ln>
+            <a:noFill/>
+          </a:ln>
+          <a:effectLst/>
+        </p:spPr>
+        <p:style>
+          <a:lnRef idx="1">
+            <a:schemeClr val="accent1"/>
+          </a:lnRef>
+          <a:fillRef idx="3">
+            <a:schemeClr val="accent1"/>
+          </a:fillRef>
+          <a:effectRef idx="2">
+            <a:schemeClr val="accent1"/>
+          </a:effectRef>
+          <a:fontRef idx="minor">
+            <a:schemeClr val="lt1"/>
+          </a:fontRef>
+        </p:style>
+        <p:txBody>
+          <a:bodyPr rtlCol="0" anchor="ctr"/>
+          <a:lstStyle/>
+          <a:p>
+            <a:pPr algn="ctr"/>
+          </a:p>
+        </p:txBody>
+      </p:sp>
+      <p:pic>
+        <p:nvPicPr>
+          <p:cNvPr id="29" name="Picture 28" descr="search.png"/>
+          <p:cNvPicPr>
+            <a:picLocks noChangeAspect="1"/>
+          </p:cNvPicPr>
+          <p:nvPr/>
+        </p:nvPicPr>
+        <p:blipFill>
+          <a:blip r:embed="rId5"/>
+          <a:stretch>
+            <a:fillRect/>
+          </a:stretch>
+        </p:blipFill>
+        <p:spPr>
+          <a:xfrm>
+            <a:off x="9386316" y="2724912"/>
+            <a:ext cx="329184" cy="329184"/>
+          </a:xfrm>
+          <a:prstGeom prst="rect">
+            <a:avLst/>
+          </a:prstGeom>
+        </p:spPr>
+      </p:pic>
+      <p:sp>
+        <p:nvSpPr>
+          <p:cNvPr id="30" name="TextBox 29"/>
+          <p:cNvSpPr txBox="1"/>
+          <p:nvPr/>
+        </p:nvSpPr>
+        <p:spPr>
+          <a:xfrm>
+            <a:off x="8590788" y="3474720"/>
+            <a:ext cx="1920240" cy="960120"/>
+          </a:xfrm>
+          <a:prstGeom prst="rect">
+            <a:avLst/>
+          </a:prstGeom>
+          <a:noFill/>
+        </p:spPr>
+        <p:txBody>
+          <a:bodyPr wrap="square" lIns="0" rIns="0" tIns="0" bIns="0" anchor="ctr">
+            <a:spAutoFit/>
+          </a:bodyPr>
+          <a:lstStyle/>
+          <a:p>
+            <a:pPr algn="ctr"/>
+            <a:r>
+              <a:rPr sz="1450" b="1">
+                <a:solidFill>
+                  <a:srgbClr val="17323A"/>
+                </a:solidFill>
+                <a:latin typeface="Cambria"/>
+              </a:rPr>
+              <a:t>Nepnieuws Herkennen</a:t>
+            </a:r>
+          </a:p>
+        </p:txBody>
+      </p:sp>
+      <p:sp>
+        <p:nvSpPr>
+          <p:cNvPr id="31" name="TextBox 30"/>
+          <p:cNvSpPr txBox="1"/>
+          <p:nvPr/>
+        </p:nvSpPr>
+        <p:spPr>
+          <a:xfrm>
+            <a:off x="8618220" y="4480560"/>
+            <a:ext cx="1865376" cy="1280160"/>
+          </a:xfrm>
+          <a:prstGeom prst="rect">
+            <a:avLst/>
+          </a:prstGeom>
+          <a:noFill/>
+        </p:spPr>
+        <p:txBody>
+          <a:bodyPr wrap="square" lIns="0" rIns="0" tIns="0" bIns="0" anchor="ctr">
+            <a:spAutoFit/>
+          </a:bodyPr>
+          <a:lstStyle/>
+          <a:p>
+            <a:pPr algn="ctr">
+              <a:lnSpc>
+                <a:spcPct val="125000"/>
+              </a:lnSpc>
+            </a:pPr>
+            <a:r>
+              <a:rPr sz="1100" b="0">
+                <a:solidFill>
+                  <a:srgbClr val="45585C"/>
+                </a:solidFill>
+                <a:latin typeface="Calibri"/>
+              </a:rPr>
+              <a:t>Een bron checken, nep van echt onderscheiden</a:t>
+            </a:r>
+          </a:p>
+        </p:txBody>
+      </p:sp>
+    </p:spTree>
+  </p:cSld>
+  <p:clrMapOvr>
+    <a:masterClrMapping/>
+  </p:clrMapOvr>
+</p:sld>
+</file>
+
 <file path=ppt/slides/slide2.xml><?xml version="1.0" encoding="utf-8"?>
 <p:sld xmlns:a="http://schemas.openxmlformats.org/drawingml/2006/main" xmlns:r="http://schemas.openxmlformats.org/officeDocument/2006/relationships" xmlns:p="http://schemas.openxmlformats.org/presentationml/2006/main">
   <p:cSld name="Slide 2">
@@ -4121,7 +5294,7 @@
                 <a:ea typeface="Calibri" pitchFamily="34" charset="-122"/>
                 <a:cs typeface="Calibri" pitchFamily="34" charset="-120"/>
               </a:rPr>
-              <a:t>INHOUD</a:t>
+              <a:t>AVOND 1</a:t>
             </a:r>
             <a:endParaRPr lang="en-US" sz="1200" dirty="0"/>
           </a:p>
@@ -4160,7 +5333,7 @@
                 <a:ea typeface="Cambria" pitchFamily="34" charset="-122"/>
                 <a:cs typeface="Cambria" pitchFamily="34" charset="-120"/>
               </a:rPr>
-              <a:t>De vijf onderwerpen</a:t>
+              <a:t>Avond 1: vijf onderwerpen</a:t>
             </a:r>
             <a:endParaRPr lang="en-US" sz="3200" dirty="0"/>
           </a:p>
@@ -4192,6 +5365,10 @@
             <a:prstDash val="solid"/>
           </a:ln>
         </p:spPr>
+        <p:txBody>
+          <a:bodyPr/>
+          <a:p/>
+        </p:txBody>
       </p:sp>
       <p:sp>
         <p:nvSpPr>
@@ -4212,6 +5389,10 @@
           </a:solidFill>
           <a:ln/>
         </p:spPr>
+        <p:txBody>
+          <a:bodyPr/>
+          <a:p/>
+        </p:txBody>
       </p:sp>
       <p:sp>
         <p:nvSpPr>
@@ -4271,6 +5452,10 @@
           </a:solidFill>
           <a:ln/>
         </p:spPr>
+        <p:txBody>
+          <a:bodyPr/>
+          <a:p/>
+        </p:txBody>
       </p:sp>
       <p:pic>
         <p:nvPicPr>
@@ -4403,6 +5588,10 @@
             <a:prstDash val="solid"/>
           </a:ln>
         </p:spPr>
+        <p:txBody>
+          <a:bodyPr/>
+          <a:p/>
+        </p:txBody>
       </p:sp>
       <p:sp>
         <p:nvSpPr>
@@ -4423,6 +5612,10 @@
           </a:solidFill>
           <a:ln/>
         </p:spPr>
+        <p:txBody>
+          <a:bodyPr/>
+          <a:p/>
+        </p:txBody>
       </p:sp>
       <p:sp>
         <p:nvSpPr>
@@ -4482,6 +5675,10 @@
           </a:solidFill>
           <a:ln/>
         </p:spPr>
+        <p:txBody>
+          <a:bodyPr/>
+          <a:p/>
+        </p:txBody>
       </p:sp>
       <p:pic>
         <p:nvPicPr>
@@ -4614,6 +5811,10 @@
             <a:prstDash val="solid"/>
           </a:ln>
         </p:spPr>
+        <p:txBody>
+          <a:bodyPr/>
+          <a:p/>
+        </p:txBody>
       </p:sp>
       <p:sp>
         <p:nvSpPr>
@@ -4634,6 +5835,10 @@
           </a:solidFill>
           <a:ln/>
         </p:spPr>
+        <p:txBody>
+          <a:bodyPr/>
+          <a:p/>
+        </p:txBody>
       </p:sp>
       <p:sp>
         <p:nvSpPr>
@@ -4693,6 +5898,10 @@
           </a:solidFill>
           <a:ln/>
         </p:spPr>
+        <p:txBody>
+          <a:bodyPr/>
+          <a:p/>
+        </p:txBody>
       </p:sp>
       <p:pic>
         <p:nvPicPr>
@@ -4825,6 +6034,10 @@
             <a:prstDash val="solid"/>
           </a:ln>
         </p:spPr>
+        <p:txBody>
+          <a:bodyPr/>
+          <a:p/>
+        </p:txBody>
       </p:sp>
       <p:sp>
         <p:nvSpPr>
@@ -4845,6 +6058,10 @@
           </a:solidFill>
           <a:ln/>
         </p:spPr>
+        <p:txBody>
+          <a:bodyPr/>
+          <a:p/>
+        </p:txBody>
       </p:sp>
       <p:sp>
         <p:nvSpPr>
@@ -4904,6 +6121,10 @@
           </a:solidFill>
           <a:ln/>
         </p:spPr>
+        <p:txBody>
+          <a:bodyPr/>
+          <a:p/>
+        </p:txBody>
       </p:sp>
       <p:pic>
         <p:nvPicPr>
@@ -5036,6 +6257,10 @@
             <a:prstDash val="solid"/>
           </a:ln>
         </p:spPr>
+        <p:txBody>
+          <a:bodyPr/>
+          <a:p/>
+        </p:txBody>
       </p:sp>
       <p:sp>
         <p:nvSpPr>
@@ -5056,6 +6281,10 @@
           </a:solidFill>
           <a:ln/>
         </p:spPr>
+        <p:txBody>
+          <a:bodyPr/>
+          <a:p/>
+        </p:txBody>
       </p:sp>
       <p:sp>
         <p:nvSpPr>
@@ -5115,6 +6344,10 @@
           </a:solidFill>
           <a:ln/>
         </p:spPr>
+        <p:txBody>
+          <a:bodyPr/>
+          <a:p/>
+        </p:txBody>
       </p:sp>
       <p:pic>
         <p:nvPicPr>
@@ -6960,6 +8193,10 @@
             <a:prstDash val="solid"/>
           </a:ln>
         </p:spPr>
+        <p:txBody>
+          <a:bodyPr/>
+          <a:p/>
+        </p:txBody>
       </p:sp>
       <p:sp>
         <p:nvSpPr>
@@ -7068,6 +8305,10 @@
             <a:prstDash val="solid"/>
           </a:ln>
         </p:spPr>
+        <p:txBody>
+          <a:bodyPr/>
+          <a:p/>
+        </p:txBody>
       </p:sp>
       <p:sp>
         <p:nvSpPr>
@@ -7144,7 +8385,7 @@
                 <a:ea typeface="Calibri" pitchFamily="34" charset="-122"/>
                 <a:cs typeface="Calibri" pitchFamily="34" charset="-120"/>
               </a:rPr>
-              <a:t>Deel 1: 30 september 2026     ·     Deel 2: 28 oktober 2026</a:t>
+              <a:t>Deel 1: 30 sept. 2026 — module 1–5     ·     Deel 2: 28 okt. 2026 — module 6–9</a:t>
             </a:r>
             <a:endParaRPr lang="en-US" sz="1450" dirty="0"/>
           </a:p>
@@ -7176,6 +8417,10 @@
             <a:prstDash val="solid"/>
           </a:ln>
         </p:spPr>
+        <p:txBody>
+          <a:bodyPr/>
+          <a:p/>
+        </p:txBody>
       </p:sp>
       <p:sp>
         <p:nvSpPr>
@@ -7284,6 +8529,10 @@
             <a:prstDash val="solid"/>
           </a:ln>
         </p:spPr>
+        <p:txBody>
+          <a:bodyPr/>
+          <a:p/>
+        </p:txBody>
       </p:sp>
       <p:sp>
         <p:nvSpPr>

</xml_diff>